<commit_message>
docs(week10): la portada de la presentacion con la fecha del 21
</commit_message>
<xml_diff>
--- a/deliveries/week10/PresentationWeek10.pptx
+++ b/deliveries/week10/PresentationWeek10.pptx
@@ -131,14 +131,14 @@
   <p:extLst>
     <p:ext uri="{521415D9-36F7-43E2-AB2F-B90AF26B5E84}">
       <p14:sectionLst xmlns:p14="http://schemas.microsoft.com/office/powerpoint/2010/main">
-        <p14:section name="Apertura" id="{12feef6d-9657-ffff-b180-ee4ca8352685}">
+        <p14:section name="Apertura" id="{8eb06f1c-dd2e-8dfa-1f42-173204631c57}">
           <p14:sldIdLst>
             <p14:sldId id="256"/>
             <p14:sldId id="257"/>
             <p14:sldId id="258"/>
           </p14:sldIdLst>
         </p14:section>
-        <p14:section name="La app" id="{f3dacc39-5f20-8d00-83a8-3f979ed6417f}">
+        <p14:section name="La app" id="{6ffcfc0b-4628-dac7-0035-99f6a39b7f89}">
           <p14:sldIdLst>
             <p14:sldId id="259"/>
             <p14:sldId id="260"/>
@@ -148,14 +148,14 @@
             <p14:sldId id="264"/>
           </p14:sldIdLst>
         </p14:section>
-        <p14:section name="Arquitectura" id="{781eaec9-9305-0ac5-1d26-49bb68bd0b94}">
+        <p14:section name="Arquitectura" id="{4af2063c-41eb-b5c3-8c3e-b67a3ee4b927}">
           <p14:sldIdLst>
             <p14:sldId id="265"/>
             <p14:sldId id="266"/>
             <p14:sldId id="267"/>
           </p14:sldIdLst>
         </p14:section>
-        <p14:section name="Motor y API" id="{a99a52af-e7e0-fa36-c59d-d75cb55b39ee}">
+        <p14:section name="Motor y API" id="{5ccc23dc-eacf-d427-8b4b-ef4b03b70bb9}">
           <p14:sldIdLst>
             <p14:sldId id="268"/>
             <p14:sldId id="269"/>
@@ -163,7 +163,7 @@
             <p14:sldId id="271"/>
           </p14:sldIdLst>
         </p14:section>
-        <p14:section name="Datos y modelo" id="{bd7aadac-d246-8a8a-a905-0306b08ea847}">
+        <p14:section name="Datos y modelo" id="{0fdc32a0-b372-212f-6970-cbac5034d167}">
           <p14:sldIdLst>
             <p14:sldId id="272"/>
             <p14:sldId id="273"/>
@@ -173,7 +173,7 @@
             <p14:sldId id="277"/>
           </p14:sldIdLst>
         </p14:section>
-        <p14:section name="Cierre" id="{61370b02-e82a-2b77-9245-1adff6df97c1}">
+        <p14:section name="Cierre" id="{5a6af5ff-6e61-62e0-13ca-10e2e2e7c908}">
           <p14:sldIdLst>
             <p14:sldId id="278"/>
             <p14:sldId id="279"/>
@@ -3934,7 +3934,7 @@
                 <a:ea typeface="Quattrocento Sans" pitchFamily="34" charset="-122"/>
                 <a:cs typeface="Quattrocento Sans" pitchFamily="34" charset="-120"/>
               </a:rPr>
-              <a:t>14 de octubre de 2026</a:t>
+              <a:t>21 de octubre de 2026</a:t>
             </a:r>
             <a:endParaRPr lang="en-US" sz="1600" dirty="0"/>
           </a:p>

</xml_diff>